<commit_message>
Competition materials: add repository link, phone and competition name
</commit_message>
<xml_diff>
--- a/competition/ClaimAI_pitch-deck.pptx
+++ b/competition/ClaimAI_pitch-deck.pptx
@@ -2135,7 +2135,7 @@
         <p:spPr>
           <a:xfrm>
             <a:off x="822960" y="3840480"/>
-            <a:ext cx="3657600" cy="365760"/>
+            <a:ext cx="10515600" cy="365760"/>
           </a:xfrm>
           <a:prstGeom prst="rect">
             <a:avLst/>
@@ -2159,7 +2159,7 @@
                 <a:ea typeface="Calibri" pitchFamily="34" charset="-122"/>
                 <a:cs typeface="Calibri" pitchFamily="34" charset="-120"/>
               </a:rPr>
-              <a:t>Pitch-deck</a:t>
+              <a:t>Республиканский конкурс студенческих проектов и исследований · Ассоциация Банков РК</a:t>
             </a:r>
             <a:endParaRPr lang="en-US" sz="1600" dirty="0"/>
           </a:p>
@@ -2241,7 +2241,7 @@
                 <a:ea typeface="Calibri" pitchFamily="34" charset="-122"/>
                 <a:cs typeface="Calibri" pitchFamily="34" charset="-120"/>
               </a:rPr>
-              <a:t>Алматы, ул. Манаса, 34/1  ·  alibig860@gmail.com</a:t>
+              <a:t>Алматы, ул. Манаса, 34/1  ·  alibig860@gmail.com  ·  +7 777 034 79 76</a:t>
             </a:r>
             <a:endParaRPr lang="en-US" sz="1500" dirty="0"/>
           </a:p>
@@ -4505,7 +4505,7 @@
                 <a:ea typeface="Calibri" pitchFamily="34" charset="-122"/>
                 <a:cs typeface="Calibri" pitchFamily="34" charset="-120"/>
               </a:rPr>
-              <a:t>[ссылка на GitHub]</a:t>
+              <a:t>github.com/AliDamn/hack</a:t>
             </a:r>
             <a:endParaRPr lang="en-US" sz="1600" dirty="0"/>
           </a:p>
@@ -4624,7 +4624,7 @@
                 <a:ea typeface="Calibri" pitchFamily="34" charset="-122"/>
                 <a:cs typeface="Calibri" pitchFamily="34" charset="-120"/>
               </a:rPr>
-              <a:t>alibig860@gmail.com</a:t>
+              <a:t>alibig860@gmail.com · +7 777 034 79 76</a:t>
             </a:r>
             <a:endParaRPr lang="en-US" sz="1600" dirty="0"/>
           </a:p>

</xml_diff>

<commit_message>
Remove demo placeholders from competition materials
</commit_message>
<xml_diff>
--- a/competition/ClaimAI_pitch-deck.pptx
+++ b/competition/ClaimAI_pitch-deck.pptx
@@ -2495,7 +2495,7 @@
                 <a:ea typeface="Calibri" pitchFamily="34" charset="-122"/>
                 <a:cs typeface="Calibri" pitchFamily="34" charset="-120"/>
               </a:rPr>
-              <a:t>Рабочий прототип, 4 демо-кейса, журнал аудита, развёртывание в облаке</a:t>
+              <a:t>Рабочий прототип, 4 демо-кейса, журнал аудита, конфигурация облачного развёртывания</a:t>
             </a:r>
             <a:endParaRPr lang="en-US" sz="1400" dirty="0"/>
           </a:p>
@@ -4539,57 +4539,6 @@
                 <a:ea typeface="Calibri" pitchFamily="34" charset="-122"/>
                 <a:cs typeface="Calibri" pitchFamily="34" charset="-120"/>
               </a:rPr>
-              <a:t>Демо</a:t>
-            </a:r>
-            <a:endParaRPr lang="en-US" sz="1600" dirty="0"/>
-          </a:p>
-          <a:p>
-            <a:pPr indent="0" marL="0">
-              <a:buNone/>
-            </a:pPr>
-            <a:r>
-              <a:rPr lang="en-US" sz="1600" dirty="0">
-                <a:solidFill>
-                  <a:srgbClr val="FFFFFF"/>
-                </a:solidFill>
-                <a:latin typeface="Calibri" pitchFamily="34" charset="0"/>
-                <a:ea typeface="Calibri" pitchFamily="34" charset="-122"/>
-                <a:cs typeface="Calibri" pitchFamily="34" charset="-120"/>
-              </a:rPr>
-              <a:t>[ссылка на работающий прототип]</a:t>
-            </a:r>
-            <a:endParaRPr lang="en-US" sz="1600" dirty="0"/>
-          </a:p>
-          <a:p>
-            <a:pPr indent="0" marL="0">
-              <a:buNone/>
-            </a:pPr>
-            <a:r>
-              <a:rPr lang="en-US" sz="1600" dirty="0">
-                <a:solidFill>
-                  <a:srgbClr val="000000"/>
-                </a:solidFill>
-                <a:latin typeface="Calibri" pitchFamily="34" charset="0"/>
-                <a:ea typeface="Calibri" pitchFamily="34" charset="-122"/>
-                <a:cs typeface="Calibri" pitchFamily="34" charset="-120"/>
-              </a:rPr>
-              <a:t> </a:t>
-            </a:r>
-            <a:endParaRPr lang="en-US" sz="1600" dirty="0"/>
-          </a:p>
-          <a:p>
-            <a:pPr indent="0" marL="0">
-              <a:buNone/>
-            </a:pPr>
-            <a:r>
-              <a:rPr lang="en-US" sz="1600" b="1" dirty="0">
-                <a:solidFill>
-                  <a:srgbClr val="B08D3C"/>
-                </a:solidFill>
-                <a:latin typeface="Calibri" pitchFamily="34" charset="0"/>
-                <a:ea typeface="Calibri" pitchFamily="34" charset="-122"/>
-                <a:cs typeface="Calibri" pitchFamily="34" charset="-120"/>
-              </a:rPr>
               <a:t>Автор</a:t>
             </a:r>
             <a:endParaRPr lang="en-US" sz="1600" dirty="0"/>
@@ -9269,7 +9218,7 @@
                 <a:ea typeface="Calibri" pitchFamily="34" charset="-122"/>
                 <a:cs typeface="Calibri" pitchFamily="34" charset="-120"/>
               </a:rPr>
-              <a:t>Docker Compose для локального запуска; интерфейс на Vercel, API и база на Render. Ключи хранятся в переменных окружения.</a:t>
+              <a:t>Docker Compose для локального запуска; подготовлена конфигурация для Vercel (интерфейс) и Render (API и база). Ключи хранятся в переменных окружения.</a:t>
             </a:r>
             <a:endParaRPr lang="en-US" sz="1400" dirty="0"/>
           </a:p>

</xml_diff>